<commit_message>
Name both team members everywhere (Liam Howeth and Richard Oduma)
Co-Authored-By: Claude Opus 5.5 <noreply@anthropic.com>
</commit_message>
<xml_diff>
--- a/docs/deck/final/Still_Here_Final.pptx
+++ b/docs/deck/final/Still_Here_Final.pptx
@@ -132,7 +132,7 @@
   <p:extLst>
     <p:ext uri="{521415D9-36F7-43E2-AB2F-B90AF26B5E84}">
       <p14:sectionLst xmlns:p14="http://schemas.microsoft.com/office/powerpoint/2010/main">
-        <p14:section name="Opening" id="{71c38a70-d20a-6c0a-480a-e22b57a48cf6}">
+        <p14:section name="Opening" id="{d8561fee-3dcd-4135-9913-490a3f55c2d3}">
           <p14:sldIdLst>
             <p14:sldId id="256"/>
             <p14:sldId id="257"/>
@@ -141,7 +141,7 @@
             <p14:sldId id="260"/>
           </p14:sldIdLst>
         </p14:section>
-        <p14:section name="Demo" id="{e1a833df-9b38-c75c-1e6e-3e4a2130bce3}">
+        <p14:section name="Demo" id="{e63b49ae-0488-1fba-8a1e-558ecc36ea76}">
           <p14:sldIdLst>
             <p14:sldId id="261"/>
             <p14:sldId id="262"/>
@@ -149,7 +149,7 @@
             <p14:sldId id="264"/>
           </p14:sldIdLst>
         </p14:section>
-        <p14:section name="How it works" id="{fe49e445-3a71-1265-bfdc-f8d142c33e55}">
+        <p14:section name="How it works" id="{f3679fe7-8602-a5b5-0b5f-91f61ca8726f}">
           <p14:sldIdLst>
             <p14:sldId id="265"/>
             <p14:sldId id="266"/>
@@ -157,21 +157,21 @@
             <p14:sldId id="268"/>
           </p14:sldIdLst>
         </p14:section>
-        <p14:section name="Trust" id="{ebe0d582-1065-f11f-8c47-838c355b43db}">
+        <p14:section name="Trust" id="{5462525e-e047-6d3d-aa4b-c47b32e7b316}">
           <p14:sldIdLst>
             <p14:sldId id="269"/>
             <p14:sldId id="270"/>
             <p14:sldId id="271"/>
           </p14:sldIdLst>
         </p14:section>
-        <p14:section name="Close" id="{ba817a09-e1eb-8ffc-081b-9dd69070f786}">
+        <p14:section name="Close" id="{71c064e7-b1de-083d-c939-93a89ca6873c}">
           <p14:sldIdLst>
             <p14:sldId id="272"/>
             <p14:sldId id="273"/>
             <p14:sldId id="274"/>
           </p14:sldIdLst>
         </p14:section>
-        <p14:section name="Backup" id="{051c3ef0-a01c-9711-3461-3a9eb306bcca}">
+        <p14:section name="Backup" id="{6cdc1768-1bf3-6984-5854-693fd9eb0abe}">
           <p14:sldIdLst>
             <p14:sldId id="275"/>
             <p14:sldId id="276"/>
@@ -1467,7 +1467,7 @@
             <a:r>
               <a:rPr lang="en-US" dirty="0"/>
               <a:t>Everything here was built today, starting at 9 AM: face control with calibration, hands-free listening, AI suggestions, natural voice, a native iPad app and a Railway backend. We have 586 passing automated tests. And we're clear about what we haven't proven: we haven't measured gesture reliability on people, and no AAC user has tested it yet.
-[Re-run node scripts/smoke-deployed.mjs against the current deploy before citing 6/6 for it. Built with Claude Code under Liam's direction.]</a:t>
+[Re-run node scripts/smoke-deployed.mjs against the current deploy before citing 6/6 for it. Built with Claude Code under the team's direction.]</a:t>
             </a:r>
             <a:endParaRPr lang="en-US" dirty="0"/>
           </a:p>
@@ -4151,7 +4151,7 @@
                   <a:srgbClr val="9AA0A8"/>
                 </a:solidFill>
               </a:rPr>
-              <a:t>SASEHacks for Good  ·  October 24, 2026</a:t>
+              <a:t>Liam Howeth  ·  Richard Oduma  ·  SASEHacks for Good</a:t>
             </a:r>
             <a:endParaRPr lang="en-US" sz="1200" dirty="0"/>
           </a:p>

</xml_diff>